<commit_message>
docs: sign classifier hyperparameters on the technical slide
</commit_message>
<xml_diff>
--- a/docs/SignBridge-workflow.pptx
+++ b/docs/SignBridge-workflow.pptx
@@ -7387,7 +7387,7 @@
                 <a:ea typeface="Arial" pitchFamily="34" charset="-122"/>
                 <a:cs typeface="Arial" pitchFamily="34" charset="-120"/>
               </a:rPr>
-              <a:t>PyTorch, 22 classes (21 signs + NONE)</a:t>
+              <a:t>PyTorch · logistic regression, 22 classes</a:t>
             </a:r>
             <a:endParaRPr lang="en-US" sz="675" dirty="0"/>
           </a:p>
@@ -8992,6 +8992,170 @@
         <p:spPr>
           <a:xfrm>
             <a:off x="4397265" y="4788288"/>
+            <a:ext cx="3641253" cy="231547"/>
+          </a:xfrm>
+          <a:prstGeom prst="rect">
+            <a:avLst/>
+          </a:prstGeom>
+          <a:noFill/>
+          <a:ln/>
+        </p:spPr>
+        <p:txBody>
+          <a:bodyPr wrap="square" lIns="0" tIns="0" rIns="0" bIns="0" rtlCol="0" anchor="t"/>
+          <a:lstStyle/>
+          <a:p>
+            <a:pPr algn="l" indent="0" marL="0">
+              <a:lnSpc>
+                <a:spcPts val="816"/>
+              </a:lnSpc>
+              <a:buNone/>
+            </a:pPr>
+            <a:r>
+              <a:rPr lang="en-US" sz="637" dirty="0">
+                <a:solidFill>
+                  <a:srgbClr val="1B2433"/>
+                </a:solidFill>
+                <a:latin typeface="Arial" pitchFamily="34" charset="0"/>
+                <a:ea typeface="Arial" pitchFamily="34" charset="-122"/>
+                <a:cs typeface="Arial" pitchFamily="34" charset="-120"/>
+              </a:rPr>
+              <a:t>input: 32 steps × 141 features → 7 stats each (mean, std, min, max, 3 thirds) = 987 values,</a:t>
+            </a:r>
+            <a:endParaRPr lang="en-US" sz="637" dirty="0"/>
+          </a:p>
+          <a:p>
+            <a:pPr algn="l" indent="0" marL="0">
+              <a:lnSpc>
+                <a:spcPts val="816"/>
+              </a:lnSpc>
+              <a:buNone/>
+            </a:pPr>
+            <a:r>
+              <a:rPr lang="en-US" sz="637" dirty="0">
+                <a:solidFill>
+                  <a:srgbClr val="1B2433"/>
+                </a:solidFill>
+                <a:latin typeface="Arial" pitchFamily="34" charset="0"/>
+                <a:ea typeface="Arial" pitchFamily="34" charset="-122"/>
+                <a:cs typeface="Arial" pitchFamily="34" charset="-120"/>
+              </a:rPr>
+              <a:t>standardized</a:t>
+            </a:r>
+            <a:endParaRPr lang="en-US" sz="637" dirty="0"/>
+          </a:p>
+        </p:txBody>
+      </p:sp>
+      <p:sp>
+        <p:nvSpPr>
+          <p:cNvPr id="143" name="Shape 141"/>
+          <p:cNvSpPr/>
+          <p:nvPr/>
+        </p:nvSpPr>
+        <p:spPr>
+          <a:xfrm>
+            <a:off x="4325829" y="5052839"/>
+            <a:ext cx="28574" cy="28574"/>
+          </a:xfrm>
+          <a:prstGeom prst="ellipse">
+            <a:avLst/>
+          </a:prstGeom>
+          <a:solidFill>
+            <a:srgbClr val="5B6578"/>
+          </a:solidFill>
+          <a:ln/>
+        </p:spPr>
+      </p:sp>
+      <p:sp>
+        <p:nvSpPr>
+          <p:cNvPr id="144" name="Text 142"/>
+          <p:cNvSpPr txBox="1"/>
+          <p:nvPr/>
+        </p:nvSpPr>
+        <p:spPr>
+          <a:xfrm>
+            <a:off x="4397265" y="5019359"/>
+            <a:ext cx="3641253" cy="231547"/>
+          </a:xfrm>
+          <a:prstGeom prst="rect">
+            <a:avLst/>
+          </a:prstGeom>
+          <a:noFill/>
+          <a:ln/>
+        </p:spPr>
+        <p:txBody>
+          <a:bodyPr wrap="square" lIns="0" tIns="0" rIns="0" bIns="0" rtlCol="0" anchor="t"/>
+          <a:lstStyle/>
+          <a:p>
+            <a:pPr algn="l" indent="0" marL="0">
+              <a:lnSpc>
+                <a:spcPts val="816"/>
+              </a:lnSpc>
+              <a:buNone/>
+            </a:pPr>
+            <a:r>
+              <a:rPr lang="en-US" sz="637" dirty="0">
+                <a:solidFill>
+                  <a:srgbClr val="1B2433"/>
+                </a:solidFill>
+                <a:latin typeface="Arial" pitchFamily="34" charset="0"/>
+                <a:ea typeface="Arial" pitchFamily="34" charset="-122"/>
+                <a:cs typeface="Arial" pitchFamily="34" charset="-120"/>
+              </a:rPr>
+              <a:t>model: multinomial logistic regression = 1 linear layer 987 → 22 (21,736 params), softmax +</a:t>
+            </a:r>
+            <a:endParaRPr lang="en-US" sz="637" dirty="0"/>
+          </a:p>
+          <a:p>
+            <a:pPr algn="l" indent="0" marL="0">
+              <a:lnSpc>
+                <a:spcPts val="816"/>
+              </a:lnSpc>
+              <a:buNone/>
+            </a:pPr>
+            <a:r>
+              <a:rPr lang="en-US" sz="637" dirty="0">
+                <a:solidFill>
+                  <a:srgbClr val="1B2433"/>
+                </a:solidFill>
+                <a:latin typeface="Arial" pitchFamily="34" charset="0"/>
+                <a:ea typeface="Arial" pitchFamily="34" charset="-122"/>
+                <a:cs typeface="Arial" pitchFamily="34" charset="-120"/>
+              </a:rPr>
+              <a:t>cross-entropy</a:t>
+            </a:r>
+            <a:endParaRPr lang="en-US" sz="637" dirty="0"/>
+          </a:p>
+        </p:txBody>
+      </p:sp>
+      <p:sp>
+        <p:nvSpPr>
+          <p:cNvPr id="145" name="Shape 143"/>
+          <p:cNvSpPr/>
+          <p:nvPr/>
+        </p:nvSpPr>
+        <p:spPr>
+          <a:xfrm>
+            <a:off x="4325829" y="5283909"/>
+            <a:ext cx="28574" cy="28574"/>
+          </a:xfrm>
+          <a:prstGeom prst="ellipse">
+            <a:avLst/>
+          </a:prstGeom>
+          <a:solidFill>
+            <a:srgbClr val="5B6578"/>
+          </a:solidFill>
+          <a:ln/>
+        </p:spPr>
+      </p:sp>
+      <p:sp>
+        <p:nvSpPr>
+          <p:cNvPr id="146" name="Text 144"/>
+          <p:cNvSpPr txBox="1"/>
+          <p:nvPr/>
+        </p:nvSpPr>
+        <p:spPr>
+          <a:xfrm>
+            <a:off x="4397265" y="5250430"/>
             <a:ext cx="3641253" cy="127918"/>
           </a:xfrm>
           <a:prstGeom prst="rect">
@@ -9019,7 +9183,7 @@
                 <a:ea typeface="Arial" pitchFamily="34" charset="-122"/>
                 <a:cs typeface="Arial" pitchFamily="34" charset="-120"/>
               </a:rPr>
-              <a:t>features: 141 per frame (hand shape relative to the wrist, upper body, nose), 32 time steps</a:t>
+              <a:t>training: L-BFGS (300 it.), L2 λ = 0.001, temperature 1.53 fitted on a held-out signer</a:t>
             </a:r>
             <a:endParaRPr lang="en-US" sz="637" dirty="0"/>
           </a:p>
@@ -9027,13 +9191,13 @@
       </p:sp>
       <p:sp>
         <p:nvSpPr>
-          <p:cNvPr id="143" name="Shape 141"/>
-          <p:cNvSpPr/>
-          <p:nvPr/>
-        </p:nvSpPr>
-        <p:spPr>
-          <a:xfrm>
-            <a:off x="4325829" y="4949209"/>
+          <p:cNvPr id="147" name="Shape 145"/>
+          <p:cNvSpPr/>
+          <p:nvPr/>
+        </p:nvSpPr>
+        <p:spPr>
+          <a:xfrm>
+            <a:off x="4325829" y="5411351"/>
             <a:ext cx="28574" cy="28574"/>
           </a:xfrm>
           <a:prstGeom prst="ellipse">
@@ -9047,14 +9211,14 @@
       </p:sp>
       <p:sp>
         <p:nvSpPr>
-          <p:cNvPr id="144" name="Text 142"/>
-          <p:cNvSpPr txBox="1"/>
-          <p:nvPr/>
-        </p:nvSpPr>
-        <p:spPr>
-          <a:xfrm>
-            <a:off x="4397265" y="4915730"/>
-            <a:ext cx="3641253" cy="231547"/>
+          <p:cNvPr id="148" name="Text 146"/>
+          <p:cNvSpPr txBox="1"/>
+          <p:nvPr/>
+        </p:nvSpPr>
+        <p:spPr>
+          <a:xfrm>
+            <a:off x="4397265" y="5377871"/>
+            <a:ext cx="3641253" cy="127918"/>
           </a:xfrm>
           <a:prstGeom prst="rect">
             <a:avLst/>
@@ -9081,117 +9245,15 @@
                 <a:ea typeface="Arial" pitchFamily="34" charset="-122"/>
                 <a:cs typeface="Arial" pitchFamily="34" charset="-120"/>
               </a:rPr>
-              <a:t>model kept: logistic regression on per-take statistics (mean, std, min, max, thirds), L-BFGS,</a:t>
+              <a:t>beat a 2-layer BiGRU (AdamW, augmentation): 89.8 % vs 87.9 % (leave-one-signer-out)</a:t>
             </a:r>
             <a:endParaRPr lang="en-US" sz="637" dirty="0"/>
           </a:p>
-          <a:p>
-            <a:pPr algn="l" indent="0" marL="0">
-              <a:lnSpc>
-                <a:spcPts val="816"/>
-              </a:lnSpc>
-              <a:buNone/>
-            </a:pPr>
-            <a:r>
-              <a:rPr lang="en-US" sz="637" dirty="0">
-                <a:solidFill>
-                  <a:srgbClr val="1B2433"/>
-                </a:solidFill>
-                <a:latin typeface="Arial" pitchFamily="34" charset="0"/>
-                <a:ea typeface="Arial" pitchFamily="34" charset="-122"/>
-                <a:cs typeface="Arial" pitchFamily="34" charset="-120"/>
-              </a:rPr>
-              <a:t>temperature-calibrated</a:t>
-            </a:r>
-            <a:endParaRPr lang="en-US" sz="637" dirty="0"/>
-          </a:p>
-        </p:txBody>
-      </p:sp>
-      <p:sp>
-        <p:nvSpPr>
-          <p:cNvPr id="145" name="Shape 143"/>
-          <p:cNvSpPr/>
-          <p:nvPr/>
-        </p:nvSpPr>
-        <p:spPr>
-          <a:xfrm>
-            <a:off x="4325829" y="5180280"/>
-            <a:ext cx="28574" cy="28574"/>
-          </a:xfrm>
-          <a:prstGeom prst="ellipse">
-            <a:avLst/>
-          </a:prstGeom>
-          <a:solidFill>
-            <a:srgbClr val="5B6578"/>
-          </a:solidFill>
-          <a:ln/>
-        </p:spPr>
-      </p:sp>
-      <p:sp>
-        <p:nvSpPr>
-          <p:cNvPr id="146" name="Text 144"/>
-          <p:cNvSpPr txBox="1"/>
-          <p:nvPr/>
-        </p:nvSpPr>
-        <p:spPr>
-          <a:xfrm>
-            <a:off x="4397265" y="5146800"/>
-            <a:ext cx="3641253" cy="231547"/>
-          </a:xfrm>
-          <a:prstGeom prst="rect">
-            <a:avLst/>
-          </a:prstGeom>
-          <a:noFill/>
-          <a:ln/>
-        </p:spPr>
-        <p:txBody>
-          <a:bodyPr wrap="square" lIns="0" tIns="0" rIns="0" bIns="0" rtlCol="0" anchor="t"/>
-          <a:lstStyle/>
-          <a:p>
-            <a:pPr algn="l" indent="0" marL="0">
-              <a:lnSpc>
-                <a:spcPts val="816"/>
-              </a:lnSpc>
-              <a:buNone/>
-            </a:pPr>
-            <a:r>
-              <a:rPr lang="en-US" sz="637" dirty="0">
-                <a:solidFill>
-                  <a:srgbClr val="1B2433"/>
-                </a:solidFill>
-                <a:latin typeface="Arial" pitchFamily="34" charset="0"/>
-                <a:ea typeface="Arial" pitchFamily="34" charset="-122"/>
-                <a:cs typeface="Arial" pitchFamily="34" charset="-120"/>
-              </a:rPr>
-              <a:t>vs a 2-layer BiGRU (AdamW, augmentation): the simpler model won, 89.8 % vs 87.9 %</a:t>
-            </a:r>
-            <a:endParaRPr lang="en-US" sz="637" dirty="0"/>
-          </a:p>
-          <a:p>
-            <a:pPr algn="l" indent="0" marL="0">
-              <a:lnSpc>
-                <a:spcPts val="816"/>
-              </a:lnSpc>
-              <a:buNone/>
-            </a:pPr>
-            <a:r>
-              <a:rPr lang="en-US" sz="637" dirty="0">
-                <a:solidFill>
-                  <a:srgbClr val="1B2433"/>
-                </a:solidFill>
-                <a:latin typeface="Arial" pitchFamily="34" charset="0"/>
-                <a:ea typeface="Arial" pitchFamily="34" charset="-122"/>
-                <a:cs typeface="Arial" pitchFamily="34" charset="-120"/>
-              </a:rPr>
-              <a:t>(leave-one-signer-out)</a:t>
-            </a:r>
-            <a:endParaRPr lang="en-US" sz="637" dirty="0"/>
-          </a:p>
-        </p:txBody>
-      </p:sp>
-      <p:sp>
-        <p:nvSpPr>
-          <p:cNvPr id="147" name="Shape 145"/>
+        </p:txBody>
+      </p:sp>
+      <p:sp>
+        <p:nvSpPr>
+          <p:cNvPr id="149" name="Shape 147"/>
           <p:cNvSpPr/>
           <p:nvPr/>
         </p:nvSpPr>
@@ -9218,7 +9280,7 @@
       </p:sp>
       <p:sp>
         <p:nvSpPr>
-          <p:cNvPr id="148" name="Shape 146"/>
+          <p:cNvPr id="150" name="Shape 148"/>
           <p:cNvSpPr/>
           <p:nvPr/>
         </p:nvSpPr>
@@ -9240,7 +9302,7 @@
       </p:sp>
       <p:sp>
         <p:nvSpPr>
-          <p:cNvPr id="149" name="Shape 147"/>
+          <p:cNvPr id="151" name="Shape 149"/>
           <p:cNvSpPr/>
           <p:nvPr/>
         </p:nvSpPr>
@@ -9260,7 +9322,7 @@
       </p:sp>
       <p:sp>
         <p:nvSpPr>
-          <p:cNvPr id="150" name="Text 148"/>
+          <p:cNvPr id="152" name="Text 150"/>
           <p:cNvSpPr txBox="1"/>
           <p:nvPr/>
         </p:nvSpPr>
@@ -9302,7 +9364,7 @@
       </p:sp>
       <p:sp>
         <p:nvSpPr>
-          <p:cNvPr id="151" name="Text 149"/>
+          <p:cNvPr id="153" name="Text 151"/>
           <p:cNvSpPr txBox="1"/>
           <p:nvPr/>
         </p:nvSpPr>
@@ -9344,7 +9406,7 @@
       </p:sp>
       <p:sp>
         <p:nvSpPr>
-          <p:cNvPr id="152" name="Shape 150"/>
+          <p:cNvPr id="154" name="Shape 152"/>
           <p:cNvSpPr/>
           <p:nvPr/>
         </p:nvSpPr>
@@ -9364,7 +9426,7 @@
       </p:sp>
       <p:sp>
         <p:nvSpPr>
-          <p:cNvPr id="153" name="Text 151"/>
+          <p:cNvPr id="155" name="Text 153"/>
           <p:cNvSpPr txBox="1"/>
           <p:nvPr/>
         </p:nvSpPr>
@@ -9406,7 +9468,7 @@
       </p:sp>
       <p:sp>
         <p:nvSpPr>
-          <p:cNvPr id="154" name="Shape 152"/>
+          <p:cNvPr id="156" name="Shape 154"/>
           <p:cNvSpPr/>
           <p:nvPr/>
         </p:nvSpPr>
@@ -9426,7 +9488,7 @@
       </p:sp>
       <p:sp>
         <p:nvSpPr>
-          <p:cNvPr id="155" name="Text 153"/>
+          <p:cNvPr id="157" name="Text 155"/>
           <p:cNvSpPr txBox="1"/>
           <p:nvPr/>
         </p:nvSpPr>
@@ -9488,7 +9550,7 @@
       </p:sp>
       <p:sp>
         <p:nvSpPr>
-          <p:cNvPr id="156" name="Shape 154"/>
+          <p:cNvPr id="158" name="Shape 156"/>
           <p:cNvSpPr/>
           <p:nvPr/>
         </p:nvSpPr>
@@ -9508,7 +9570,7 @@
       </p:sp>
       <p:sp>
         <p:nvSpPr>
-          <p:cNvPr id="157" name="Text 155"/>
+          <p:cNvPr id="159" name="Text 157"/>
           <p:cNvSpPr txBox="1"/>
           <p:nvPr/>
         </p:nvSpPr>
@@ -9550,7 +9612,7 @@
       </p:sp>
       <p:sp>
         <p:nvSpPr>
-          <p:cNvPr id="158" name="Shape 156"/>
+          <p:cNvPr id="160" name="Shape 158"/>
           <p:cNvSpPr/>
           <p:nvPr/>
         </p:nvSpPr>
@@ -9570,7 +9632,7 @@
       </p:sp>
       <p:sp>
         <p:nvSpPr>
-          <p:cNvPr id="159" name="Text 157"/>
+          <p:cNvPr id="161" name="Text 159"/>
           <p:cNvSpPr txBox="1"/>
           <p:nvPr/>
         </p:nvSpPr>
@@ -9612,7 +9674,7 @@
       </p:sp>
       <p:sp>
         <p:nvSpPr>
-          <p:cNvPr id="160" name="Shape 158"/>
+          <p:cNvPr id="162" name="Shape 160"/>
           <p:cNvSpPr/>
           <p:nvPr/>
         </p:nvSpPr>
@@ -9639,7 +9701,7 @@
       </p:sp>
       <p:sp>
         <p:nvSpPr>
-          <p:cNvPr id="161" name="Text 159"/>
+          <p:cNvPr id="163" name="Text 161"/>
           <p:cNvSpPr txBox="1"/>
           <p:nvPr/>
         </p:nvSpPr>
@@ -9681,7 +9743,7 @@
       </p:sp>
       <p:sp>
         <p:nvSpPr>
-          <p:cNvPr id="162" name="Text 160"/>
+          <p:cNvPr id="164" name="Text 162"/>
           <p:cNvSpPr txBox="1"/>
           <p:nvPr/>
         </p:nvSpPr>
@@ -9743,7 +9805,7 @@
       </p:sp>
       <p:sp>
         <p:nvSpPr>
-          <p:cNvPr id="163" name="Shape 161"/>
+          <p:cNvPr id="165" name="Shape 163"/>
           <p:cNvSpPr/>
           <p:nvPr/>
         </p:nvSpPr>
@@ -9770,7 +9832,7 @@
       </p:sp>
       <p:sp>
         <p:nvSpPr>
-          <p:cNvPr id="164" name="Text 162"/>
+          <p:cNvPr id="166" name="Text 164"/>
           <p:cNvSpPr txBox="1"/>
           <p:nvPr/>
         </p:nvSpPr>
@@ -9812,7 +9874,7 @@
       </p:sp>
       <p:sp>
         <p:nvSpPr>
-          <p:cNvPr id="165" name="Text 163"/>
+          <p:cNvPr id="167" name="Text 165"/>
           <p:cNvSpPr txBox="1"/>
           <p:nvPr/>
         </p:nvSpPr>
@@ -9874,7 +9936,7 @@
       </p:sp>
       <p:sp>
         <p:nvSpPr>
-          <p:cNvPr id="166" name="Shape 164"/>
+          <p:cNvPr id="168" name="Shape 166"/>
           <p:cNvSpPr/>
           <p:nvPr/>
         </p:nvSpPr>
@@ -9901,7 +9963,7 @@
       </p:sp>
       <p:sp>
         <p:nvSpPr>
-          <p:cNvPr id="167" name="Text 165"/>
+          <p:cNvPr id="169" name="Text 167"/>
           <p:cNvSpPr txBox="1"/>
           <p:nvPr/>
         </p:nvSpPr>
@@ -9943,7 +10005,7 @@
       </p:sp>
       <p:sp>
         <p:nvSpPr>
-          <p:cNvPr id="168" name="Text 166"/>
+          <p:cNvPr id="170" name="Text 168"/>
           <p:cNvSpPr txBox="1"/>
           <p:nvPr/>
         </p:nvSpPr>

</xml_diff>

<commit_message>
docs: appendix slide, why our own sign classifier instead of an open-source model
</commit_message>
<xml_diff>
--- a/docs/SignBridge-workflow.pptx
+++ b/docs/SignBridge-workflow.pptx
@@ -7,9 +7,10 @@
   <p:sldIdLst>
     <p:sldId id="256" r:id="rId2"/>
     <p:sldId id="257" r:id="rId3"/>
+    <p:sldId id="258" r:id="rId4"/>
   </p:sldIdLst>
   <p:notesMasterIdLst>
-    <p:notesMasterId r:id="rId4"/>
+    <p:notesMasterId r:id="rId5"/>
   </p:notesMasterIdLst>
   <p:sldSz cx="12192000" cy="6858000"/>
   <p:notesSz cx="6858000" cy="12192000"/>
@@ -633,6 +634,94 @@
 </p:notes>
 </file>
 
+<file path=ppt/notesSlides/notesSlide3.xml><?xml version="1.0" encoding="utf-8"?>
+<p:notes xmlns:a="http://schemas.openxmlformats.org/drawingml/2006/main" xmlns:r="http://schemas.openxmlformats.org/officeDocument/2006/relationships" xmlns:p="http://schemas.openxmlformats.org/presentationml/2006/main">
+  <p:cSld>
+    <p:spTree>
+      <p:nvGrpSpPr>
+        <p:cNvPr id="1" name=""/>
+        <p:cNvGrpSpPr/>
+        <p:nvPr/>
+      </p:nvGrpSpPr>
+      <p:grpSpPr>
+        <a:xfrm>
+          <a:off x="0" y="0"/>
+          <a:ext cx="0" cy="0"/>
+          <a:chOff x="0" y="0"/>
+          <a:chExt cx="0" cy="0"/>
+        </a:xfrm>
+      </p:grpSpPr>
+      <p:sp>
+        <p:nvSpPr>
+          <p:cNvPr id="2" name="Slide Image Placeholder 1"/>
+          <p:cNvSpPr>
+            <a:spLocks noGrp="1" noRot="1" noChangeAspect="1"/>
+          </p:cNvSpPr>
+          <p:nvPr>
+            <p:ph type="sldImg"/>
+          </p:nvPr>
+        </p:nvSpPr>
+        <p:spPr/>
+      </p:sp>
+      <p:sp>
+        <p:nvSpPr>
+          <p:cNvPr id="3" name="Notes Placeholder 2"/>
+          <p:cNvSpPr>
+            <a:spLocks noGrp="1"/>
+          </p:cNvSpPr>
+          <p:nvPr>
+            <p:ph type="body" idx="1"/>
+          </p:nvPr>
+        </p:nvSpPr>
+        <p:spPr/>
+        <p:txBody>
+          <a:bodyPr/>
+          <a:lstStyle/>
+          <a:p>
+            <a:r>
+              <a:rPr lang="en-US" dirty="0"/>
+              <a:t/>
+            </a:r>
+            <a:endParaRPr lang="en-US" dirty="0"/>
+          </a:p>
+        </p:txBody>
+      </p:sp>
+      <p:sp>
+        <p:nvSpPr>
+          <p:cNvPr id="4" name="Slide Number Placeholder 3"/>
+          <p:cNvSpPr>
+            <a:spLocks noGrp="1"/>
+          </p:cNvSpPr>
+          <p:nvPr>
+            <p:ph type="sldNum" sz="quarter" idx="10"/>
+          </p:nvPr>
+        </p:nvSpPr>
+        <p:spPr/>
+        <p:txBody>
+          <a:bodyPr/>
+          <a:lstStyle/>
+          <a:p>
+            <a:fld id="{F7021451-1387-4CA6-816F-3879F97B5CBC}" type="slidenum">
+              <a:rPr lang="en-US"/>
+              <a:t>3</a:t>
+            </a:fld>
+            <a:endParaRPr lang="en-US"/>
+          </a:p>
+        </p:txBody>
+      </p:sp>
+    </p:spTree>
+    <p:extLst>
+      <p:ext uri="{BB962C8B-B14F-4D97-AF65-F5344CB8AC3E}">
+        <p14:creationId xmlns:p14="http://schemas.microsoft.com/office/powerpoint/2010/main" val="1024086991"/>
+      </p:ext>
+    </p:extLst>
+  </p:cSld>
+  <p:clrMapOvr>
+    <a:masterClrMapping/>
+  </p:clrMapOvr>
+</p:notes>
+</file>
+
 <file path=ppt/slideLayouts/slideLayout1.xml><?xml version="1.0" encoding="utf-8"?>
 <p:sldLayout xmlns:a="http://schemas.openxmlformats.org/drawingml/2006/main" xmlns:r="http://schemas.openxmlformats.org/officeDocument/2006/relationships" xmlns:p="http://schemas.openxmlformats.org/presentationml/2006/main" preserve="1">
   <p:cSld name="DEFAULT">
@@ -10062,6 +10151,1362 @@
               <a:t>8 live, unguided</a:t>
             </a:r>
             <a:endParaRPr lang="en-US" sz="630" dirty="0"/>
+          </a:p>
+        </p:txBody>
+      </p:sp>
+    </p:spTree>
+  </p:cSld>
+  <p:clrMapOvr>
+    <a:masterClrMapping/>
+  </p:clrMapOvr>
+</p:sld>
+</file>
+
+<file path=ppt/slides/slide3.xml><?xml version="1.0" encoding="utf-8"?>
+<p:sld xmlns:a="http://schemas.openxmlformats.org/drawingml/2006/main" xmlns:r="http://schemas.openxmlformats.org/officeDocument/2006/relationships" xmlns:p="http://schemas.openxmlformats.org/presentationml/2006/main">
+  <p:cSld name="Slide 3">
+    <p:spTree>
+      <p:nvGrpSpPr>
+        <p:cNvPr id="1" name=""/>
+        <p:cNvGrpSpPr/>
+        <p:nvPr/>
+      </p:nvGrpSpPr>
+      <p:grpSpPr>
+        <a:xfrm>
+          <a:off x="0" y="0"/>
+          <a:ext cx="0" cy="0"/>
+          <a:chOff x="0" y="0"/>
+          <a:chExt cx="0" cy="0"/>
+        </a:xfrm>
+      </p:grpSpPr>
+      <p:sp>
+        <p:nvSpPr>
+          <p:cNvPr id="2" name="Shape 0"/>
+          <p:cNvSpPr/>
+          <p:nvPr/>
+        </p:nvSpPr>
+        <p:spPr>
+          <a:xfrm>
+            <a:off x="0" y="0"/>
+            <a:ext cx="12191695" cy="6857829"/>
+          </a:xfrm>
+          <a:prstGeom prst="rect">
+            <a:avLst/>
+          </a:prstGeom>
+          <a:solidFill>
+            <a:srgbClr val="FFFFFF"/>
+          </a:solidFill>
+          <a:ln/>
+        </p:spPr>
+      </p:sp>
+      <p:sp>
+        <p:nvSpPr>
+          <p:cNvPr id="3" name="Shape 1"/>
+          <p:cNvSpPr/>
+          <p:nvPr/>
+        </p:nvSpPr>
+        <p:spPr>
+          <a:xfrm>
+            <a:off x="0" y="0"/>
+            <a:ext cx="12191695" cy="590535"/>
+          </a:xfrm>
+          <a:prstGeom prst="rect">
+            <a:avLst/>
+          </a:prstGeom>
+          <a:solidFill>
+            <a:srgbClr val="0E2A47"/>
+          </a:solidFill>
+          <a:ln/>
+        </p:spPr>
+      </p:sp>
+      <p:sp>
+        <p:nvSpPr>
+          <p:cNvPr id="4" name="Text 2"/>
+          <p:cNvSpPr txBox="1"/>
+          <p:nvPr/>
+        </p:nvSpPr>
+        <p:spPr>
+          <a:xfrm>
+            <a:off x="304792" y="151634"/>
+            <a:ext cx="4761312" cy="342891"/>
+          </a:xfrm>
+          <a:prstGeom prst="rect">
+            <a:avLst/>
+          </a:prstGeom>
+          <a:noFill/>
+          <a:ln/>
+        </p:spPr>
+        <p:txBody>
+          <a:bodyPr wrap="square" lIns="0" tIns="0" rIns="0" bIns="0" rtlCol="0" anchor="t"/>
+          <a:lstStyle/>
+          <a:p>
+            <a:pPr algn="l" indent="0" marL="0">
+              <a:lnSpc>
+                <a:spcPts val="2160"/>
+              </a:lnSpc>
+              <a:buNone/>
+            </a:pPr>
+            <a:r>
+              <a:rPr lang="en-US" sz="1800" b="1" dirty="0">
+                <a:solidFill>
+                  <a:srgbClr val="FFFFFF"/>
+                </a:solidFill>
+                <a:latin typeface="Arial" pitchFamily="34" charset="0"/>
+                <a:ea typeface="Arial" pitchFamily="34" charset="-122"/>
+                <a:cs typeface="Arial" pitchFamily="34" charset="-120"/>
+              </a:rPr>
+              <a:t>Appendix — why our own sign classifier?</a:t>
+            </a:r>
+            <a:endParaRPr lang="en-US" sz="1800" dirty="0"/>
+          </a:p>
+        </p:txBody>
+      </p:sp>
+      <p:sp>
+        <p:nvSpPr>
+          <p:cNvPr id="5" name="Text 3"/>
+          <p:cNvSpPr txBox="1"/>
+          <p:nvPr/>
+        </p:nvSpPr>
+        <p:spPr>
+          <a:xfrm>
+            <a:off x="304792" y="431853"/>
+            <a:ext cx="4354383" cy="150015"/>
+          </a:xfrm>
+          <a:prstGeom prst="rect">
+            <a:avLst/>
+          </a:prstGeom>
+          <a:noFill/>
+          <a:ln/>
+        </p:spPr>
+        <p:txBody>
+          <a:bodyPr wrap="square" lIns="0" tIns="0" rIns="0" bIns="0" rtlCol="0" anchor="t"/>
+          <a:lstStyle/>
+          <a:p>
+            <a:pPr algn="l" indent="0" marL="0">
+              <a:lnSpc>
+                <a:spcPts val="945"/>
+              </a:lnSpc>
+              <a:buNone/>
+            </a:pPr>
+            <a:r>
+              <a:rPr lang="en-US" sz="787" dirty="0">
+                <a:solidFill>
+                  <a:srgbClr val="C9D6EA"/>
+                </a:solidFill>
+                <a:latin typeface="Arial" pitchFamily="34" charset="0"/>
+                <a:ea typeface="Arial" pitchFamily="34" charset="-122"/>
+                <a:cs typeface="Arial" pitchFamily="34" charset="-120"/>
+              </a:rPr>
+              <a:t>We use open source where it is strong, and trained only the last layer on our hotel vocabulary</a:t>
+            </a:r>
+            <a:endParaRPr lang="en-US" sz="787" dirty="0"/>
+          </a:p>
+        </p:txBody>
+      </p:sp>
+      <p:sp>
+        <p:nvSpPr>
+          <p:cNvPr id="6" name="Text 4"/>
+          <p:cNvSpPr txBox="1"/>
+          <p:nvPr/>
+        </p:nvSpPr>
+        <p:spPr>
+          <a:xfrm>
+            <a:off x="304792" y="851704"/>
+            <a:ext cx="1210405" cy="164302"/>
+          </a:xfrm>
+          <a:prstGeom prst="rect">
+            <a:avLst/>
+          </a:prstGeom>
+          <a:noFill/>
+          <a:ln/>
+        </p:spPr>
+        <p:txBody>
+          <a:bodyPr wrap="square" lIns="0" tIns="0" rIns="0" bIns="0" rtlCol="0" anchor="t"/>
+          <a:lstStyle/>
+          <a:p>
+            <a:pPr algn="l" indent="0" marL="0">
+              <a:lnSpc>
+                <a:spcPts val="1035"/>
+              </a:lnSpc>
+              <a:buNone/>
+            </a:pPr>
+            <a:r>
+              <a:rPr lang="en-US" sz="862" b="1" dirty="0">
+                <a:solidFill>
+                  <a:srgbClr val="0E2A47"/>
+                </a:solidFill>
+                <a:latin typeface="Arial" pitchFamily="34" charset="0"/>
+                <a:ea typeface="Arial" pitchFamily="34" charset="-122"/>
+                <a:cs typeface="Arial" pitchFamily="34" charset="-120"/>
+              </a:rPr>
+              <a:t>WHAT WE CHECKED</a:t>
+            </a:r>
+            <a:endParaRPr lang="en-US" sz="862" dirty="0"/>
+          </a:p>
+        </p:txBody>
+      </p:sp>
+      <p:sp>
+        <p:nvSpPr>
+          <p:cNvPr id="7" name="Shape 5"/>
+          <p:cNvSpPr/>
+          <p:nvPr/>
+        </p:nvSpPr>
+        <p:spPr>
+          <a:xfrm>
+            <a:off x="304792" y="1238219"/>
+            <a:ext cx="5714857" cy="781030"/>
+          </a:xfrm>
+          <a:prstGeom prst="roundRect">
+            <a:avLst>
+              <a:gd name="adj" fmla="val 9756"/>
+            </a:avLst>
+          </a:prstGeom>
+          <a:solidFill>
+            <a:srgbClr val="F5F7FA"/>
+          </a:solidFill>
+          <a:ln w="9525">
+            <a:solidFill>
+              <a:srgbClr val="D5DCE5"/>
+            </a:solidFill>
+            <a:prstDash val="solid"/>
+          </a:ln>
+        </p:spPr>
+      </p:sp>
+      <p:sp>
+        <p:nvSpPr>
+          <p:cNvPr id="8" name="Text 6"/>
+          <p:cNvSpPr txBox="1"/>
+          <p:nvPr/>
+        </p:nvSpPr>
+        <p:spPr>
+          <a:xfrm>
+            <a:off x="457189" y="1342610"/>
+            <a:ext cx="1650403" cy="171446"/>
+          </a:xfrm>
+          <a:prstGeom prst="rect">
+            <a:avLst/>
+          </a:prstGeom>
+          <a:noFill/>
+          <a:ln/>
+        </p:spPr>
+        <p:txBody>
+          <a:bodyPr wrap="square" lIns="0" tIns="0" rIns="0" bIns="0" rtlCol="0" anchor="t"/>
+          <a:lstStyle/>
+          <a:p>
+            <a:pPr algn="l" indent="0" marL="0">
+              <a:lnSpc>
+                <a:spcPts val="1080"/>
+              </a:lnSpc>
+              <a:buNone/>
+            </a:pPr>
+            <a:r>
+              <a:rPr lang="en-US" sz="900" b="1" dirty="0">
+                <a:solidFill>
+                  <a:srgbClr val="0E2A47"/>
+                </a:solidFill>
+                <a:latin typeface="Arial" pitchFamily="34" charset="0"/>
+                <a:ea typeface="Arial" pitchFamily="34" charset="-122"/>
+                <a:cs typeface="Arial" pitchFamily="34" charset="-120"/>
+              </a:rPr>
+              <a:t>Open sign-language models</a:t>
+            </a:r>
+            <a:endParaRPr lang="en-US" sz="900" dirty="0"/>
+          </a:p>
+        </p:txBody>
+      </p:sp>
+      <p:sp>
+        <p:nvSpPr>
+          <p:cNvPr id="9" name="Text 7"/>
+          <p:cNvSpPr txBox="1"/>
+          <p:nvPr/>
+        </p:nvSpPr>
+        <p:spPr>
+          <a:xfrm>
+            <a:off x="457189" y="1527200"/>
+            <a:ext cx="5645517" cy="287172"/>
+          </a:xfrm>
+          <a:prstGeom prst="rect">
+            <a:avLst/>
+          </a:prstGeom>
+          <a:noFill/>
+          <a:ln/>
+        </p:spPr>
+        <p:txBody>
+          <a:bodyPr wrap="square" lIns="0" tIns="0" rIns="0" bIns="0" rtlCol="0" anchor="t"/>
+          <a:lstStyle/>
+          <a:p>
+            <a:pPr algn="l" indent="0" marL="0">
+              <a:lnSpc>
+                <a:spcPts val="1012"/>
+              </a:lnSpc>
+              <a:buNone/>
+            </a:pPr>
+            <a:r>
+              <a:rPr lang="en-US" sz="787" dirty="0">
+                <a:solidFill>
+                  <a:srgbClr val="1B2433"/>
+                </a:solidFill>
+                <a:latin typeface="Arial" pitchFamily="34" charset="0"/>
+                <a:ea typeface="Arial" pitchFamily="34" charset="-122"/>
+                <a:cs typeface="Arial" pitchFamily="34" charset="-120"/>
+              </a:rPr>
+              <a:t>recognize isolated signs from their own vocabulary, or fingerspelling (Kaggle competitions); none translated hotel</a:t>
+            </a:r>
+            <a:endParaRPr lang="en-US" sz="787" dirty="0"/>
+          </a:p>
+          <a:p>
+            <a:pPr algn="l" indent="0" marL="0">
+              <a:lnSpc>
+                <a:spcPts val="1012"/>
+              </a:lnSpc>
+              <a:buNone/>
+            </a:pPr>
+            <a:r>
+              <a:rPr lang="en-US" sz="787" dirty="0">
+                <a:solidFill>
+                  <a:srgbClr val="1B2433"/>
+                </a:solidFill>
+                <a:latin typeface="Arial" pitchFamily="34" charset="0"/>
+                <a:ea typeface="Arial" pitchFamily="34" charset="-122"/>
+                <a:cs typeface="Arial" pitchFamily="34" charset="-120"/>
+              </a:rPr>
+              <a:t>conversations reliably when we started</a:t>
+            </a:r>
+            <a:endParaRPr lang="en-US" sz="787" dirty="0"/>
+          </a:p>
+        </p:txBody>
+      </p:sp>
+      <p:sp>
+        <p:nvSpPr>
+          <p:cNvPr id="10" name="Shape 8"/>
+          <p:cNvSpPr/>
+          <p:nvPr/>
+        </p:nvSpPr>
+        <p:spPr>
+          <a:xfrm>
+            <a:off x="304792" y="2171646"/>
+            <a:ext cx="5714857" cy="781030"/>
+          </a:xfrm>
+          <a:prstGeom prst="roundRect">
+            <a:avLst>
+              <a:gd name="adj" fmla="val 9756"/>
+            </a:avLst>
+          </a:prstGeom>
+          <a:solidFill>
+            <a:srgbClr val="F5F7FA"/>
+          </a:solidFill>
+          <a:ln w="9525">
+            <a:solidFill>
+              <a:srgbClr val="D5DCE5"/>
+            </a:solidFill>
+            <a:prstDash val="solid"/>
+          </a:ln>
+        </p:spPr>
+      </p:sp>
+      <p:sp>
+        <p:nvSpPr>
+          <p:cNvPr id="11" name="Text 9"/>
+          <p:cNvSpPr txBox="1"/>
+          <p:nvPr/>
+        </p:nvSpPr>
+        <p:spPr>
+          <a:xfrm>
+            <a:off x="457189" y="2276037"/>
+            <a:ext cx="2700722" cy="171446"/>
+          </a:xfrm>
+          <a:prstGeom prst="rect">
+            <a:avLst/>
+          </a:prstGeom>
+          <a:noFill/>
+          <a:ln/>
+        </p:spPr>
+        <p:txBody>
+          <a:bodyPr wrap="square" lIns="0" tIns="0" rIns="0" bIns="0" rtlCol="0" anchor="t"/>
+          <a:lstStyle/>
+          <a:p>
+            <a:pPr algn="l" indent="0" marL="0">
+              <a:lnSpc>
+                <a:spcPts val="1080"/>
+              </a:lnSpc>
+              <a:buNone/>
+            </a:pPr>
+            <a:r>
+              <a:rPr lang="en-US" sz="900" b="1" dirty="0">
+                <a:solidFill>
+                  <a:srgbClr val="0E2A47"/>
+                </a:solidFill>
+                <a:latin typeface="Arial" pitchFamily="34" charset="0"/>
+                <a:ea typeface="Arial" pitchFamily="34" charset="-122"/>
+                <a:cs typeface="Arial" pitchFamily="34" charset="-120"/>
+              </a:rPr>
+              <a:t>Google ASL dataset (Kaggle GISLR, 250 signs)</a:t>
+            </a:r>
+            <a:endParaRPr lang="en-US" sz="900" dirty="0"/>
+          </a:p>
+        </p:txBody>
+      </p:sp>
+      <p:sp>
+        <p:nvSpPr>
+          <p:cNvPr id="12" name="Text 10"/>
+          <p:cNvSpPr txBox="1"/>
+          <p:nvPr/>
+        </p:nvSpPr>
+        <p:spPr>
+          <a:xfrm>
+            <a:off x="457189" y="2460627"/>
+            <a:ext cx="5645517" cy="287172"/>
+          </a:xfrm>
+          <a:prstGeom prst="rect">
+            <a:avLst/>
+          </a:prstGeom>
+          <a:noFill/>
+          <a:ln/>
+        </p:spPr>
+        <p:txBody>
+          <a:bodyPr wrap="square" lIns="0" tIns="0" rIns="0" bIns="0" rtlCol="0" anchor="t"/>
+          <a:lstStyle/>
+          <a:p>
+            <a:pPr algn="l" indent="0" marL="0">
+              <a:lnSpc>
+                <a:spcPts val="1012"/>
+              </a:lnSpc>
+              <a:buNone/>
+            </a:pPr>
+            <a:r>
+              <a:rPr lang="en-US" sz="787" dirty="0">
+                <a:solidFill>
+                  <a:srgbClr val="1B2433"/>
+                </a:solidFill>
+                <a:latin typeface="Arial" pitchFamily="34" charset="0"/>
+                <a:ea typeface="Arial" pitchFamily="34" charset="-122"/>
+                <a:cs typeface="Arial" pitchFamily="34" charset="-120"/>
+              </a:rPr>
+              <a:t>covers only 7 of our 21 signs: yes, no, please, thank you, where, time, room. Missing: reservation, elevator, towel,</a:t>
+            </a:r>
+            <a:endParaRPr lang="en-US" sz="787" dirty="0"/>
+          </a:p>
+          <a:p>
+            <a:pPr algn="l" indent="0" marL="0">
+              <a:lnSpc>
+                <a:spcPts val="1012"/>
+              </a:lnSpc>
+              <a:buNone/>
+            </a:pPr>
+            <a:r>
+              <a:rPr lang="en-US" sz="787" dirty="0">
+                <a:solidFill>
+                  <a:srgbClr val="1B2433"/>
+                </a:solidFill>
+                <a:latin typeface="Arial" pitchFamily="34" charset="0"/>
+                <a:ea typeface="Arial" pitchFamily="34" charset="-122"/>
+                <a:cs typeface="Arial" pitchFamily="34" charset="-120"/>
+              </a:rPr>
+              <a:t>breakfast, checkout, password...</a:t>
+            </a:r>
+            <a:endParaRPr lang="en-US" sz="787" dirty="0"/>
+          </a:p>
+        </p:txBody>
+      </p:sp>
+      <p:sp>
+        <p:nvSpPr>
+          <p:cNvPr id="13" name="Shape 11"/>
+          <p:cNvSpPr/>
+          <p:nvPr/>
+        </p:nvSpPr>
+        <p:spPr>
+          <a:xfrm>
+            <a:off x="304792" y="3105072"/>
+            <a:ext cx="5714857" cy="571486"/>
+          </a:xfrm>
+          <a:prstGeom prst="roundRect">
+            <a:avLst>
+              <a:gd name="adj" fmla="val 13333"/>
+            </a:avLst>
+          </a:prstGeom>
+          <a:solidFill>
+            <a:srgbClr val="F5F7FA"/>
+          </a:solidFill>
+          <a:ln w="9525">
+            <a:solidFill>
+              <a:srgbClr val="D5DCE5"/>
+            </a:solidFill>
+            <a:prstDash val="solid"/>
+          </a:ln>
+        </p:spPr>
+      </p:sp>
+      <p:sp>
+        <p:nvSpPr>
+          <p:cNvPr id="14" name="Text 12"/>
+          <p:cNvSpPr txBox="1"/>
+          <p:nvPr/>
+        </p:nvSpPr>
+        <p:spPr>
+          <a:xfrm>
+            <a:off x="457189" y="3209464"/>
+            <a:ext cx="719069" cy="171446"/>
+          </a:xfrm>
+          <a:prstGeom prst="rect">
+            <a:avLst/>
+          </a:prstGeom>
+          <a:noFill/>
+          <a:ln/>
+        </p:spPr>
+        <p:txBody>
+          <a:bodyPr wrap="square" lIns="0" tIns="0" rIns="0" bIns="0" rtlCol="0" anchor="t"/>
+          <a:lstStyle/>
+          <a:p>
+            <a:pPr algn="l" indent="0" marL="0">
+              <a:lnSpc>
+                <a:spcPts val="1080"/>
+              </a:lnSpc>
+              <a:buNone/>
+            </a:pPr>
+            <a:r>
+              <a:rPr lang="en-US" sz="900" b="1" dirty="0">
+                <a:solidFill>
+                  <a:srgbClr val="0E2A47"/>
+                </a:solidFill>
+                <a:latin typeface="Arial" pitchFamily="34" charset="0"/>
+                <a:ea typeface="Arial" pitchFamily="34" charset="-122"/>
+                <a:cs typeface="Arial" pitchFamily="34" charset="-120"/>
+              </a:rPr>
+              <a:t>ASL Citizen</a:t>
+            </a:r>
+            <a:endParaRPr lang="en-US" sz="900" dirty="0"/>
+          </a:p>
+        </p:txBody>
+      </p:sp>
+      <p:sp>
+        <p:nvSpPr>
+          <p:cNvPr id="15" name="Text 13"/>
+          <p:cNvSpPr txBox="1"/>
+          <p:nvPr/>
+        </p:nvSpPr>
+        <p:spPr>
+          <a:xfrm>
+            <a:off x="457189" y="3394054"/>
+            <a:ext cx="5645517" cy="158587"/>
+          </a:xfrm>
+          <a:prstGeom prst="rect">
+            <a:avLst/>
+          </a:prstGeom>
+          <a:noFill/>
+          <a:ln/>
+        </p:spPr>
+        <p:txBody>
+          <a:bodyPr wrap="square" lIns="0" tIns="0" rIns="0" bIns="0" rtlCol="0" anchor="t"/>
+          <a:lstStyle/>
+          <a:p>
+            <a:pPr algn="l" indent="0" marL="0">
+              <a:lnSpc>
+                <a:spcPts val="1012"/>
+              </a:lnSpc>
+              <a:buNone/>
+            </a:pPr>
+            <a:r>
+              <a:rPr lang="en-US" sz="787" dirty="0">
+                <a:solidFill>
+                  <a:srgbClr val="1B2433"/>
+                </a:solidFill>
+                <a:latin typeface="Arial" pitchFamily="34" charset="0"/>
+                <a:ea typeface="Arial" pitchFamily="34" charset="-122"/>
+                <a:cs typeface="Arial" pitchFamily="34" charset="-120"/>
+              </a:rPr>
+              <a:t>license forbids redistribution; non-commercial research use only</a:t>
+            </a:r>
+            <a:endParaRPr lang="en-US" sz="787" dirty="0"/>
+          </a:p>
+        </p:txBody>
+      </p:sp>
+      <p:sp>
+        <p:nvSpPr>
+          <p:cNvPr id="16" name="Shape 14"/>
+          <p:cNvSpPr/>
+          <p:nvPr/>
+        </p:nvSpPr>
+        <p:spPr>
+          <a:xfrm>
+            <a:off x="304792" y="3828954"/>
+            <a:ext cx="5714857" cy="571486"/>
+          </a:xfrm>
+          <a:prstGeom prst="roundRect">
+            <a:avLst>
+              <a:gd name="adj" fmla="val 13333"/>
+            </a:avLst>
+          </a:prstGeom>
+          <a:solidFill>
+            <a:srgbClr val="F5F7FA"/>
+          </a:solidFill>
+          <a:ln w="9525">
+            <a:solidFill>
+              <a:srgbClr val="D5DCE5"/>
+            </a:solidFill>
+            <a:prstDash val="solid"/>
+          </a:ln>
+        </p:spPr>
+      </p:sp>
+      <p:sp>
+        <p:nvSpPr>
+          <p:cNvPr id="17" name="Text 15"/>
+          <p:cNvSpPr txBox="1"/>
+          <p:nvPr/>
+        </p:nvSpPr>
+        <p:spPr>
+          <a:xfrm>
+            <a:off x="457189" y="3933346"/>
+            <a:ext cx="481215" cy="171446"/>
+          </a:xfrm>
+          <a:prstGeom prst="rect">
+            <a:avLst/>
+          </a:prstGeom>
+          <a:noFill/>
+          <a:ln/>
+        </p:spPr>
+        <p:txBody>
+          <a:bodyPr wrap="square" lIns="0" tIns="0" rIns="0" bIns="0" rtlCol="0" anchor="t"/>
+          <a:lstStyle/>
+          <a:p>
+            <a:pPr algn="l" indent="0" marL="0">
+              <a:lnSpc>
+                <a:spcPts val="1080"/>
+              </a:lnSpc>
+              <a:buNone/>
+            </a:pPr>
+            <a:r>
+              <a:rPr lang="en-US" sz="900" b="1" dirty="0">
+                <a:solidFill>
+                  <a:srgbClr val="0E2A47"/>
+                </a:solidFill>
+                <a:latin typeface="Arial" pitchFamily="34" charset="0"/>
+                <a:ea typeface="Arial" pitchFamily="34" charset="-122"/>
+                <a:cs typeface="Arial" pitchFamily="34" charset="-120"/>
+              </a:rPr>
+              <a:t>WLASL</a:t>
+            </a:r>
+            <a:endParaRPr lang="en-US" sz="900" dirty="0"/>
+          </a:p>
+        </p:txBody>
+      </p:sp>
+      <p:sp>
+        <p:nvSpPr>
+          <p:cNvPr id="18" name="Text 16"/>
+          <p:cNvSpPr txBox="1"/>
+          <p:nvPr/>
+        </p:nvSpPr>
+        <p:spPr>
+          <a:xfrm>
+            <a:off x="457189" y="4117936"/>
+            <a:ext cx="5645517" cy="158587"/>
+          </a:xfrm>
+          <a:prstGeom prst="rect">
+            <a:avLst/>
+          </a:prstGeom>
+          <a:noFill/>
+          <a:ln/>
+        </p:spPr>
+        <p:txBody>
+          <a:bodyPr wrap="square" lIns="0" tIns="0" rIns="0" bIns="0" rtlCol="0" anchor="t"/>
+          <a:lstStyle/>
+          <a:p>
+            <a:pPr algn="l" indent="0" marL="0">
+              <a:lnSpc>
+                <a:spcPts val="1012"/>
+              </a:lnSpc>
+              <a:buNone/>
+            </a:pPr>
+            <a:r>
+              <a:rPr lang="en-US" sz="787" dirty="0">
+                <a:solidFill>
+                  <a:srgbClr val="1B2433"/>
+                </a:solidFill>
+                <a:latin typeface="Arial" pitchFamily="34" charset="0"/>
+                <a:ea typeface="Arial" pitchFamily="34" charset="-122"/>
+                <a:cs typeface="Arial" pitchFamily="34" charset="-120"/>
+              </a:rPr>
+              <a:t>videos scraped from third-party sites, many dead links, unclear license</a:t>
+            </a:r>
+            <a:endParaRPr lang="en-US" sz="787" dirty="0"/>
+          </a:p>
+        </p:txBody>
+      </p:sp>
+      <p:sp>
+        <p:nvSpPr>
+          <p:cNvPr id="19" name="Text 17"/>
+          <p:cNvSpPr txBox="1"/>
+          <p:nvPr/>
+        </p:nvSpPr>
+        <p:spPr>
+          <a:xfrm>
+            <a:off x="6400640" y="851704"/>
+            <a:ext cx="1514107" cy="164302"/>
+          </a:xfrm>
+          <a:prstGeom prst="rect">
+            <a:avLst/>
+          </a:prstGeom>
+          <a:noFill/>
+          <a:ln/>
+        </p:spPr>
+        <p:txBody>
+          <a:bodyPr wrap="square" lIns="0" tIns="0" rIns="0" bIns="0" rtlCol="0" anchor="t"/>
+          <a:lstStyle/>
+          <a:p>
+            <a:pPr algn="l" indent="0" marL="0">
+              <a:lnSpc>
+                <a:spcPts val="1035"/>
+              </a:lnSpc>
+              <a:buNone/>
+            </a:pPr>
+            <a:r>
+              <a:rPr lang="en-US" sz="862" b="1" dirty="0">
+                <a:solidFill>
+                  <a:srgbClr val="1E9E5A"/>
+                </a:solidFill>
+                <a:latin typeface="Arial" pitchFamily="34" charset="0"/>
+                <a:ea typeface="Arial" pitchFamily="34" charset="-122"/>
+                <a:cs typeface="Arial" pitchFamily="34" charset="-120"/>
+              </a:rPr>
+              <a:t>WHAT WE BUILT INSTEAD</a:t>
+            </a:r>
+            <a:endParaRPr lang="en-US" sz="862" dirty="0"/>
+          </a:p>
+        </p:txBody>
+      </p:sp>
+      <p:sp>
+        <p:nvSpPr>
+          <p:cNvPr id="20" name="Shape 18"/>
+          <p:cNvSpPr/>
+          <p:nvPr/>
+        </p:nvSpPr>
+        <p:spPr>
+          <a:xfrm>
+            <a:off x="6400640" y="1238219"/>
+            <a:ext cx="5486263" cy="781030"/>
+          </a:xfrm>
+          <a:prstGeom prst="roundRect">
+            <a:avLst>
+              <a:gd name="adj" fmla="val 12195"/>
+            </a:avLst>
+          </a:prstGeom>
+          <a:solidFill>
+            <a:srgbClr val="F5F7FA"/>
+          </a:solidFill>
+          <a:ln w="9525">
+            <a:solidFill>
+              <a:srgbClr val="D5DCE5"/>
+            </a:solidFill>
+            <a:prstDash val="solid"/>
+          </a:ln>
+        </p:spPr>
+      </p:sp>
+      <p:sp>
+        <p:nvSpPr>
+          <p:cNvPr id="21" name="Text 19"/>
+          <p:cNvSpPr txBox="1"/>
+          <p:nvPr/>
+        </p:nvSpPr>
+        <p:spPr>
+          <a:xfrm>
+            <a:off x="6610185" y="1470623"/>
+            <a:ext cx="967603" cy="428614"/>
+          </a:xfrm>
+          <a:prstGeom prst="rect">
+            <a:avLst/>
+          </a:prstGeom>
+          <a:noFill/>
+          <a:ln/>
+        </p:spPr>
+        <p:txBody>
+          <a:bodyPr wrap="square" lIns="0" tIns="0" rIns="0" bIns="0" rtlCol="0" anchor="t"/>
+          <a:lstStyle/>
+          <a:p>
+            <a:pPr algn="l" indent="0" marL="0">
+              <a:lnSpc>
+                <a:spcPts val="2700"/>
+              </a:lnSpc>
+              <a:buNone/>
+            </a:pPr>
+            <a:r>
+              <a:rPr lang="en-US" sz="2250" b="1" dirty="0">
+                <a:solidFill>
+                  <a:srgbClr val="1E9E5A"/>
+                </a:solidFill>
+                <a:latin typeface="Arial" pitchFamily="34" charset="0"/>
+                <a:ea typeface="Arial" pitchFamily="34" charset="-122"/>
+                <a:cs typeface="Arial" pitchFamily="34" charset="-120"/>
+              </a:rPr>
+              <a:t>21,736</a:t>
+            </a:r>
+            <a:endParaRPr lang="en-US" sz="2250" dirty="0"/>
+          </a:p>
+        </p:txBody>
+      </p:sp>
+      <p:sp>
+        <p:nvSpPr>
+          <p:cNvPr id="22" name="Text 20"/>
+          <p:cNvSpPr txBox="1"/>
+          <p:nvPr/>
+        </p:nvSpPr>
+        <p:spPr>
+          <a:xfrm>
+            <a:off x="8038899" y="1609304"/>
+            <a:ext cx="3842670" cy="177161"/>
+          </a:xfrm>
+          <a:prstGeom prst="rect">
+            <a:avLst/>
+          </a:prstGeom>
+          <a:noFill/>
+          <a:ln/>
+        </p:spPr>
+        <p:txBody>
+          <a:bodyPr wrap="square" lIns="0" tIns="0" rIns="0" bIns="0" rtlCol="0" anchor="t"/>
+          <a:lstStyle/>
+          <a:p>
+            <a:pPr algn="l" indent="0" marL="0">
+              <a:lnSpc>
+                <a:spcPts val="1125"/>
+              </a:lnSpc>
+              <a:buNone/>
+            </a:pPr>
+            <a:r>
+              <a:rPr lang="en-US" sz="900" dirty="0">
+                <a:solidFill>
+                  <a:srgbClr val="1B2433"/>
+                </a:solidFill>
+                <a:latin typeface="Arial" pitchFamily="34" charset="0"/>
+                <a:ea typeface="Arial" pitchFamily="34" charset="-122"/>
+                <a:cs typeface="Arial" pitchFamily="34" charset="-120"/>
+              </a:rPr>
+              <a:t>parameters: runs in milliseconds on the laptop CPU</a:t>
+            </a:r>
+            <a:endParaRPr lang="en-US" sz="900" dirty="0"/>
+          </a:p>
+        </p:txBody>
+      </p:sp>
+      <p:sp>
+        <p:nvSpPr>
+          <p:cNvPr id="23" name="Shape 21"/>
+          <p:cNvSpPr/>
+          <p:nvPr/>
+        </p:nvSpPr>
+        <p:spPr>
+          <a:xfrm>
+            <a:off x="6400640" y="2171646"/>
+            <a:ext cx="5486263" cy="781030"/>
+          </a:xfrm>
+          <a:prstGeom prst="roundRect">
+            <a:avLst>
+              <a:gd name="adj" fmla="val 12195"/>
+            </a:avLst>
+          </a:prstGeom>
+          <a:solidFill>
+            <a:srgbClr val="F5F7FA"/>
+          </a:solidFill>
+          <a:ln w="9525">
+            <a:solidFill>
+              <a:srgbClr val="D5DCE5"/>
+            </a:solidFill>
+            <a:prstDash val="solid"/>
+          </a:ln>
+        </p:spPr>
+      </p:sp>
+      <p:sp>
+        <p:nvSpPr>
+          <p:cNvPr id="24" name="Text 22"/>
+          <p:cNvSpPr txBox="1"/>
+          <p:nvPr/>
+        </p:nvSpPr>
+        <p:spPr>
+          <a:xfrm>
+            <a:off x="6610185" y="2404050"/>
+            <a:ext cx="802329" cy="428614"/>
+          </a:xfrm>
+          <a:prstGeom prst="rect">
+            <a:avLst/>
+          </a:prstGeom>
+          <a:noFill/>
+          <a:ln/>
+        </p:spPr>
+        <p:txBody>
+          <a:bodyPr wrap="square" lIns="0" tIns="0" rIns="0" bIns="0" rtlCol="0" anchor="t"/>
+          <a:lstStyle/>
+          <a:p>
+            <a:pPr algn="l" indent="0" marL="0">
+              <a:lnSpc>
+                <a:spcPts val="2700"/>
+              </a:lnSpc>
+              <a:buNone/>
+            </a:pPr>
+            <a:r>
+              <a:rPr lang="en-US" sz="2250" b="1" dirty="0">
+                <a:solidFill>
+                  <a:srgbClr val="1E9E5A"/>
+                </a:solidFill>
+                <a:latin typeface="Arial" pitchFamily="34" charset="0"/>
+                <a:ea typeface="Arial" pitchFamily="34" charset="-122"/>
+                <a:cs typeface="Arial" pitchFamily="34" charset="-120"/>
+              </a:rPr>
+              <a:t>1,320</a:t>
+            </a:r>
+            <a:endParaRPr lang="en-US" sz="2250" dirty="0"/>
+          </a:p>
+        </p:txBody>
+      </p:sp>
+      <p:sp>
+        <p:nvSpPr>
+          <p:cNvPr id="25" name="Text 23"/>
+          <p:cNvSpPr txBox="1"/>
+          <p:nvPr/>
+        </p:nvSpPr>
+        <p:spPr>
+          <a:xfrm>
+            <a:off x="8038899" y="2542730"/>
+            <a:ext cx="3842670" cy="177161"/>
+          </a:xfrm>
+          <a:prstGeom prst="rect">
+            <a:avLst/>
+          </a:prstGeom>
+          <a:noFill/>
+          <a:ln/>
+        </p:spPr>
+        <p:txBody>
+          <a:bodyPr wrap="square" lIns="0" tIns="0" rIns="0" bIns="0" rtlCol="0" anchor="t"/>
+          <a:lstStyle/>
+          <a:p>
+            <a:pPr algn="l" indent="0" marL="0">
+              <a:lnSpc>
+                <a:spcPts val="1125"/>
+              </a:lnSpc>
+              <a:buNone/>
+            </a:pPr>
+            <a:r>
+              <a:rPr lang="en-US" sz="900" dirty="0">
+                <a:solidFill>
+                  <a:srgbClr val="1B2433"/>
+                </a:solidFill>
+                <a:latin typeface="Arial" pitchFamily="34" charset="0"/>
+                <a:ea typeface="Arial" pitchFamily="34" charset="-122"/>
+                <a:cs typeface="Arial" pitchFamily="34" charset="-120"/>
+              </a:rPr>
+              <a:t>takes recorded by 5 team members (22 classes × 12)</a:t>
+            </a:r>
+            <a:endParaRPr lang="en-US" sz="900" dirty="0"/>
+          </a:p>
+        </p:txBody>
+      </p:sp>
+      <p:sp>
+        <p:nvSpPr>
+          <p:cNvPr id="26" name="Shape 24"/>
+          <p:cNvSpPr/>
+          <p:nvPr/>
+        </p:nvSpPr>
+        <p:spPr>
+          <a:xfrm>
+            <a:off x="6400640" y="3105072"/>
+            <a:ext cx="5486263" cy="781030"/>
+          </a:xfrm>
+          <a:prstGeom prst="roundRect">
+            <a:avLst>
+              <a:gd name="adj" fmla="val 12195"/>
+            </a:avLst>
+          </a:prstGeom>
+          <a:solidFill>
+            <a:srgbClr val="F5F7FA"/>
+          </a:solidFill>
+          <a:ln w="9525">
+            <a:solidFill>
+              <a:srgbClr val="D5DCE5"/>
+            </a:solidFill>
+            <a:prstDash val="solid"/>
+          </a:ln>
+        </p:spPr>
+      </p:sp>
+      <p:sp>
+        <p:nvSpPr>
+          <p:cNvPr id="27" name="Text 25"/>
+          <p:cNvSpPr txBox="1"/>
+          <p:nvPr/>
+        </p:nvSpPr>
+        <p:spPr>
+          <a:xfrm>
+            <a:off x="6610185" y="3337477"/>
+            <a:ext cx="981678" cy="428614"/>
+          </a:xfrm>
+          <a:prstGeom prst="rect">
+            <a:avLst/>
+          </a:prstGeom>
+          <a:noFill/>
+          <a:ln/>
+        </p:spPr>
+        <p:txBody>
+          <a:bodyPr wrap="square" lIns="0" tIns="0" rIns="0" bIns="0" rtlCol="0" anchor="t"/>
+          <a:lstStyle/>
+          <a:p>
+            <a:pPr algn="l" indent="0" marL="0">
+              <a:lnSpc>
+                <a:spcPts val="2700"/>
+              </a:lnSpc>
+              <a:buNone/>
+            </a:pPr>
+            <a:r>
+              <a:rPr lang="en-US" sz="2250" b="1" dirty="0">
+                <a:solidFill>
+                  <a:srgbClr val="1E9E5A"/>
+                </a:solidFill>
+                <a:latin typeface="Arial" pitchFamily="34" charset="0"/>
+                <a:ea typeface="Arial" pitchFamily="34" charset="-122"/>
+                <a:cs typeface="Arial" pitchFamily="34" charset="-120"/>
+              </a:rPr>
+              <a:t>≈ 90 %</a:t>
+            </a:r>
+            <a:endParaRPr lang="en-US" sz="2250" dirty="0"/>
+          </a:p>
+        </p:txBody>
+      </p:sp>
+      <p:sp>
+        <p:nvSpPr>
+          <p:cNvPr id="28" name="Text 26"/>
+          <p:cNvSpPr txBox="1"/>
+          <p:nvPr/>
+        </p:nvSpPr>
+        <p:spPr>
+          <a:xfrm>
+            <a:off x="8038899" y="3476157"/>
+            <a:ext cx="3842670" cy="177161"/>
+          </a:xfrm>
+          <a:prstGeom prst="rect">
+            <a:avLst/>
+          </a:prstGeom>
+          <a:noFill/>
+          <a:ln/>
+        </p:spPr>
+        <p:txBody>
+          <a:bodyPr wrap="square" lIns="0" tIns="0" rIns="0" bIns="0" rtlCol="0" anchor="t"/>
+          <a:lstStyle/>
+          <a:p>
+            <a:pPr algn="l" indent="0" marL="0">
+              <a:lnSpc>
+                <a:spcPts val="1125"/>
+              </a:lnSpc>
+              <a:buNone/>
+            </a:pPr>
+            <a:r>
+              <a:rPr lang="en-US" sz="900" dirty="0">
+                <a:solidFill>
+                  <a:srgbClr val="1B2433"/>
+                </a:solidFill>
+                <a:latin typeface="Arial" pitchFamily="34" charset="0"/>
+                <a:ea typeface="Arial" pitchFamily="34" charset="-122"/>
+                <a:cs typeface="Arial" pitchFamily="34" charset="-120"/>
+              </a:rPr>
+              <a:t>sentences right for a signer never seen</a:t>
+            </a:r>
+            <a:endParaRPr lang="en-US" sz="900" dirty="0"/>
+          </a:p>
+        </p:txBody>
+      </p:sp>
+      <p:sp>
+        <p:nvSpPr>
+          <p:cNvPr id="29" name="Shape 27"/>
+          <p:cNvSpPr/>
+          <p:nvPr/>
+        </p:nvSpPr>
+        <p:spPr>
+          <a:xfrm>
+            <a:off x="6400640" y="4038499"/>
+            <a:ext cx="5486263" cy="781030"/>
+          </a:xfrm>
+          <a:prstGeom prst="roundRect">
+            <a:avLst>
+              <a:gd name="adj" fmla="val 12195"/>
+            </a:avLst>
+          </a:prstGeom>
+          <a:solidFill>
+            <a:srgbClr val="F5F7FA"/>
+          </a:solidFill>
+          <a:ln w="9525">
+            <a:solidFill>
+              <a:srgbClr val="D5DCE5"/>
+            </a:solidFill>
+            <a:prstDash val="solid"/>
+          </a:ln>
+        </p:spPr>
+      </p:sp>
+      <p:sp>
+        <p:nvSpPr>
+          <p:cNvPr id="30" name="Text 28"/>
+          <p:cNvSpPr txBox="1"/>
+          <p:nvPr/>
+        </p:nvSpPr>
+        <p:spPr>
+          <a:xfrm>
+            <a:off x="6610185" y="4270903"/>
+            <a:ext cx="223946" cy="428614"/>
+          </a:xfrm>
+          <a:prstGeom prst="rect">
+            <a:avLst/>
+          </a:prstGeom>
+          <a:noFill/>
+          <a:ln/>
+        </p:spPr>
+        <p:txBody>
+          <a:bodyPr wrap="square" lIns="0" tIns="0" rIns="0" bIns="0" rtlCol="0" anchor="t"/>
+          <a:lstStyle/>
+          <a:p>
+            <a:pPr algn="l" indent="0" marL="0">
+              <a:lnSpc>
+                <a:spcPts val="2700"/>
+              </a:lnSpc>
+              <a:buNone/>
+            </a:pPr>
+            <a:r>
+              <a:rPr lang="en-US" sz="2250" b="1" dirty="0">
+                <a:solidFill>
+                  <a:srgbClr val="1E9E5A"/>
+                </a:solidFill>
+                <a:latin typeface="Arial" pitchFamily="34" charset="0"/>
+                <a:ea typeface="Arial" pitchFamily="34" charset="-122"/>
+                <a:cs typeface="Arial" pitchFamily="34" charset="-120"/>
+              </a:rPr>
+              <a:t>0</a:t>
+            </a:r>
+            <a:endParaRPr lang="en-US" sz="2250" dirty="0"/>
+          </a:p>
+        </p:txBody>
+      </p:sp>
+      <p:sp>
+        <p:nvSpPr>
+          <p:cNvPr id="31" name="Text 29"/>
+          <p:cNvSpPr txBox="1"/>
+          <p:nvPr/>
+        </p:nvSpPr>
+        <p:spPr>
+          <a:xfrm>
+            <a:off x="8038899" y="4409584"/>
+            <a:ext cx="3842670" cy="177161"/>
+          </a:xfrm>
+          <a:prstGeom prst="rect">
+            <a:avLst/>
+          </a:prstGeom>
+          <a:noFill/>
+          <a:ln/>
+        </p:spPr>
+        <p:txBody>
+          <a:bodyPr wrap="square" lIns="0" tIns="0" rIns="0" bIns="0" rtlCol="0" anchor="t"/>
+          <a:lstStyle/>
+          <a:p>
+            <a:pPr algn="l" indent="0" marL="0">
+              <a:lnSpc>
+                <a:spcPts val="1125"/>
+              </a:lnSpc>
+              <a:buNone/>
+            </a:pPr>
+            <a:r>
+              <a:rPr lang="en-US" sz="900" dirty="0">
+                <a:solidFill>
+                  <a:srgbClr val="1B2433"/>
+                </a:solidFill>
+                <a:latin typeface="Arial" pitchFamily="34" charset="0"/>
+                <a:ea typeface="Arial" pitchFamily="34" charset="-122"/>
+                <a:cs typeface="Arial" pitchFamily="34" charset="-120"/>
+              </a:rPr>
+              <a:t>video frames leave the laptop: only skeleton points, processed locally</a:t>
+            </a:r>
+            <a:endParaRPr lang="en-US" sz="900" dirty="0"/>
+          </a:p>
+        </p:txBody>
+      </p:sp>
+      <p:sp>
+        <p:nvSpPr>
+          <p:cNvPr id="32" name="Shape 30"/>
+          <p:cNvSpPr/>
+          <p:nvPr/>
+        </p:nvSpPr>
+        <p:spPr>
+          <a:xfrm>
+            <a:off x="304792" y="5333867"/>
+            <a:ext cx="11582110" cy="1142971"/>
+          </a:xfrm>
+          <a:prstGeom prst="roundRect">
+            <a:avLst>
+              <a:gd name="adj" fmla="val 8333"/>
+            </a:avLst>
+          </a:prstGeom>
+          <a:solidFill>
+            <a:srgbClr val="FFF1E6"/>
+          </a:solidFill>
+          <a:ln w="19050">
+            <a:solidFill>
+              <a:srgbClr val="E8590C"/>
+            </a:solidFill>
+            <a:prstDash val="solid"/>
+          </a:ln>
+        </p:spPr>
+      </p:sp>
+      <p:sp>
+        <p:nvSpPr>
+          <p:cNvPr id="33" name="Text 31"/>
+          <p:cNvSpPr txBox="1"/>
+          <p:nvPr/>
+        </p:nvSpPr>
+        <p:spPr>
+          <a:xfrm>
+            <a:off x="495288" y="5486644"/>
+            <a:ext cx="1504182" cy="185733"/>
+          </a:xfrm>
+          <a:prstGeom prst="rect">
+            <a:avLst/>
+          </a:prstGeom>
+          <a:noFill/>
+          <a:ln/>
+        </p:spPr>
+        <p:txBody>
+          <a:bodyPr wrap="square" lIns="0" tIns="0" rIns="0" bIns="0" rtlCol="0" anchor="t"/>
+          <a:lstStyle/>
+          <a:p>
+            <a:pPr algn="l" indent="0" marL="0">
+              <a:lnSpc>
+                <a:spcPts val="1170"/>
+              </a:lnSpc>
+              <a:buNone/>
+            </a:pPr>
+            <a:r>
+              <a:rPr lang="en-US" sz="975" b="1" dirty="0">
+                <a:solidFill>
+                  <a:srgbClr val="E8590C"/>
+                </a:solidFill>
+                <a:latin typeface="Arial" pitchFamily="34" charset="0"/>
+                <a:ea typeface="Arial" pitchFamily="34" charset="-122"/>
+                <a:cs typeface="Arial" pitchFamily="34" charset="-120"/>
+              </a:rPr>
+              <a:t>Open source we do use</a:t>
+            </a:r>
+            <a:endParaRPr lang="en-US" sz="975" dirty="0"/>
+          </a:p>
+        </p:txBody>
+      </p:sp>
+      <p:sp>
+        <p:nvSpPr>
+          <p:cNvPr id="34" name="Text 32"/>
+          <p:cNvSpPr txBox="1"/>
+          <p:nvPr/>
+        </p:nvSpPr>
+        <p:spPr>
+          <a:xfrm>
+            <a:off x="495288" y="5685902"/>
+            <a:ext cx="11668214" cy="177161"/>
+          </a:xfrm>
+          <a:prstGeom prst="rect">
+            <a:avLst/>
+          </a:prstGeom>
+          <a:noFill/>
+          <a:ln/>
+        </p:spPr>
+        <p:txBody>
+          <a:bodyPr wrap="square" lIns="0" tIns="0" rIns="0" bIns="0" rtlCol="0" anchor="t"/>
+          <a:lstStyle/>
+          <a:p>
+            <a:pPr algn="l" indent="0" marL="0">
+              <a:lnSpc>
+                <a:spcPts val="1125"/>
+              </a:lnSpc>
+              <a:buNone/>
+            </a:pPr>
+            <a:r>
+              <a:rPr lang="en-US" sz="900" dirty="0">
+                <a:solidFill>
+                  <a:srgbClr val="1B2433"/>
+                </a:solidFill>
+                <a:latin typeface="Arial" pitchFamily="34" charset="0"/>
+                <a:ea typeface="Arial" pitchFamily="34" charset="-122"/>
+                <a:cs typeface="Arial" pitchFamily="34" charset="-120"/>
+              </a:rPr>
+              <a:t>MediaPipe (Google) for hand, body and face tracking · PyTorch for training · Three.js for the avatar · Next.js for the app · Whisper speech model (via the OpenAI API)</a:t>
+            </a:r>
+            <a:endParaRPr lang="en-US" sz="900" dirty="0"/>
+          </a:p>
+        </p:txBody>
+      </p:sp>
+      <p:sp>
+        <p:nvSpPr>
+          <p:cNvPr id="35" name="Text 33"/>
+          <p:cNvSpPr txBox="1"/>
+          <p:nvPr/>
+        </p:nvSpPr>
+        <p:spPr>
+          <a:xfrm>
+            <a:off x="495288" y="6124041"/>
+            <a:ext cx="633342" cy="171446"/>
+          </a:xfrm>
+          <a:prstGeom prst="rect">
+            <a:avLst/>
+          </a:prstGeom>
+          <a:noFill/>
+          <a:ln/>
+        </p:spPr>
+        <p:txBody>
+          <a:bodyPr wrap="square" lIns="0" tIns="0" rIns="0" bIns="0" rtlCol="0" anchor="t"/>
+          <a:lstStyle/>
+          <a:p>
+            <a:pPr algn="l" indent="0" marL="0">
+              <a:lnSpc>
+                <a:spcPts val="1080"/>
+              </a:lnSpc>
+              <a:buNone/>
+            </a:pPr>
+            <a:r>
+              <a:rPr lang="en-US" sz="900" b="1" dirty="0">
+                <a:solidFill>
+                  <a:srgbClr val="E8590C"/>
+                </a:solidFill>
+                <a:latin typeface="Arial" pitchFamily="34" charset="0"/>
+                <a:ea typeface="Arial" pitchFamily="34" charset="-122"/>
+                <a:cs typeface="Arial" pitchFamily="34" charset="-120"/>
+              </a:rPr>
+              <a:t>Next step:</a:t>
+            </a:r>
+            <a:endParaRPr lang="en-US" sz="900" dirty="0"/>
+          </a:p>
+        </p:txBody>
+      </p:sp>
+      <p:sp>
+        <p:nvSpPr>
+          <p:cNvPr id="36" name="Text 34"/>
+          <p:cNvSpPr txBox="1"/>
+          <p:nvPr/>
+        </p:nvSpPr>
+        <p:spPr>
+          <a:xfrm>
+            <a:off x="1124052" y="6124041"/>
+            <a:ext cx="10895430" cy="177161"/>
+          </a:xfrm>
+          <a:prstGeom prst="rect">
+            <a:avLst/>
+          </a:prstGeom>
+          <a:noFill/>
+          <a:ln/>
+        </p:spPr>
+        <p:txBody>
+          <a:bodyPr wrap="square" lIns="0" tIns="0" rIns="0" bIns="0" rtlCol="0" anchor="t"/>
+          <a:lstStyle/>
+          <a:p>
+            <a:pPr algn="l" indent="0" marL="0">
+              <a:lnSpc>
+                <a:spcPts val="1125"/>
+              </a:lnSpc>
+              <a:buNone/>
+            </a:pPr>
+            <a:r>
+              <a:rPr lang="en-US" sz="900" dirty="0">
+                <a:solidFill>
+                  <a:srgbClr val="1B2433"/>
+                </a:solidFill>
+                <a:latin typeface="Arial" pitchFamily="34" charset="0"/>
+                <a:ea typeface="Arial" pitchFamily="34" charset="-122"/>
+                <a:cs typeface="Arial" pitchFamily="34" charset="-120"/>
+              </a:rPr>
+              <a:t>when an open continuous ASL-to-English model is available, it can replace our classifier; tracking, sentence decoding, avatar and voice stay the same.</a:t>
+            </a:r>
+            <a:endParaRPr lang="en-US" sz="900" dirty="0"/>
           </a:p>
         </p:txBody>
       </p:sp>

</xml_diff>